<commit_message>
Edit to Task 4 powerpoint
</commit_message>
<xml_diff>
--- a/Task 4/CEF440_Task4_SystemModelling.pptx
+++ b/Task 4/CEF440_Task4_SystemModelling.pptx
@@ -16334,12 +16334,57 @@
           </a:ln>
         </p:spPr>
       </p:sp>
+      <p:sp>
+        <p:nvSpPr>
+          <p:cNvPr id="5" name="Text 1">
+            <a:extLst>
+              <a:ext uri="{FF2B5EF4-FFF2-40B4-BE49-F238E27FC236}">
+                <a16:creationId xmlns:a16="http://schemas.microsoft.com/office/drawing/2014/main" id="{14836256-A173-70EB-371A-D8F36AB1DE8B}"/>
+              </a:ext>
+            </a:extLst>
+          </p:cNvPr>
+          <p:cNvSpPr/>
+          <p:nvPr/>
+        </p:nvSpPr>
+        <p:spPr>
+          <a:xfrm>
+            <a:off x="274320" y="0"/>
+            <a:ext cx="3070129" cy="685800"/>
+          </a:xfrm>
+          <a:prstGeom prst="rect">
+            <a:avLst/>
+          </a:prstGeom>
+          <a:noFill/>
+          <a:ln/>
+        </p:spPr>
+        <p:txBody>
+          <a:bodyPr wrap="square" rtlCol="0" anchor="ctr"/>
+          <a:lstStyle/>
+          <a:p>
+            <a:pPr marL="0" indent="0">
+              <a:buNone/>
+            </a:pPr>
+            <a:r>
+              <a:rPr lang="en-US" sz="2000" b="1" dirty="0">
+                <a:solidFill>
+                  <a:srgbClr val="FFFFFF"/>
+                </a:solidFill>
+                <a:latin typeface="Calibri" pitchFamily="34" charset="0"/>
+                <a:ea typeface="Calibri" pitchFamily="34" charset="-122"/>
+                <a:cs typeface="Calibri" pitchFamily="34" charset="-120"/>
+              </a:rPr>
+              <a:t>System Use Case Diagram</a:t>
+            </a:r>
+            <a:endParaRPr lang="en-US" sz="2000" dirty="0"/>
+          </a:p>
+        </p:txBody>
+      </p:sp>
       <p:pic>
         <p:nvPicPr>
-          <p:cNvPr id="4" name="Picture 3">
+          <p:cNvPr id="6" name="Picture 5">
             <a:extLst>
               <a:ext uri="{FF2B5EF4-FFF2-40B4-BE49-F238E27FC236}">
-                <a16:creationId xmlns:a16="http://schemas.microsoft.com/office/drawing/2014/main" id="{1780D0A8-8A71-CC30-F22E-E24519F6C657}"/>
+                <a16:creationId xmlns:a16="http://schemas.microsoft.com/office/drawing/2014/main" id="{C5A38C05-930F-9C09-AC74-90F4888B454E}"/>
               </a:ext>
             </a:extLst>
           </p:cNvPr>
@@ -16356,59 +16401,14 @@
         </p:blipFill>
         <p:spPr>
           <a:xfrm>
-            <a:off x="1564954" y="685800"/>
-            <a:ext cx="5618723" cy="4262728"/>
+            <a:off x="1431857" y="809896"/>
+            <a:ext cx="5306811" cy="4244319"/>
           </a:xfrm>
           <a:prstGeom prst="rect">
             <a:avLst/>
           </a:prstGeom>
         </p:spPr>
       </p:pic>
-      <p:sp>
-        <p:nvSpPr>
-          <p:cNvPr id="5" name="Text 1">
-            <a:extLst>
-              <a:ext uri="{FF2B5EF4-FFF2-40B4-BE49-F238E27FC236}">
-                <a16:creationId xmlns:a16="http://schemas.microsoft.com/office/drawing/2014/main" id="{14836256-A173-70EB-371A-D8F36AB1DE8B}"/>
-              </a:ext>
-            </a:extLst>
-          </p:cNvPr>
-          <p:cNvSpPr/>
-          <p:nvPr/>
-        </p:nvSpPr>
-        <p:spPr>
-          <a:xfrm>
-            <a:off x="274320" y="0"/>
-            <a:ext cx="3070129" cy="685800"/>
-          </a:xfrm>
-          <a:prstGeom prst="rect">
-            <a:avLst/>
-          </a:prstGeom>
-          <a:noFill/>
-          <a:ln/>
-        </p:spPr>
-        <p:txBody>
-          <a:bodyPr wrap="square" rtlCol="0" anchor="ctr"/>
-          <a:lstStyle/>
-          <a:p>
-            <a:pPr marL="0" indent="0">
-              <a:buNone/>
-            </a:pPr>
-            <a:r>
-              <a:rPr lang="en-US" sz="2000" b="1" dirty="0">
-                <a:solidFill>
-                  <a:srgbClr val="FFFFFF"/>
-                </a:solidFill>
-                <a:latin typeface="Calibri" pitchFamily="34" charset="0"/>
-                <a:ea typeface="Calibri" pitchFamily="34" charset="-122"/>
-                <a:cs typeface="Calibri" pitchFamily="34" charset="-120"/>
-              </a:rPr>
-              <a:t>System Use Case Diagram</a:t>
-            </a:r>
-            <a:endParaRPr lang="en-US" sz="2000" dirty="0"/>
-          </a:p>
-        </p:txBody>
-      </p:sp>
     </p:spTree>
     <p:extLst>
       <p:ext uri="{BB962C8B-B14F-4D97-AF65-F5344CB8AC3E}">

</xml_diff>